<commit_message>
Fix skill descriptions to use official SDBQ language
- Updated all three priority gap skill descriptions to match official SDBQ "Item Description" field
  1. 10.RI.1.C: "Evaluate details in a text, determining which could confirm or disprove an argument or position"
  2. 11.RL.1.C: "Analyze how characters are revealed through particular lines of dialogue or events"
  3. 11.RVN.1.B: "Use context and sentence structure clues to clarify the meaning of words"

- Previous descriptions were paraphrased and in some cases changed the instructional focus
- Added SOL_Official_Descriptions.csv reference file containing official descriptions for all 39 tested standards
- Regenerated presentation slides 1-3 with corrected descriptions

This ensures all instructional materials reflect exact SOL standards from the SDBQ.
</commit_message>
<xml_diff>
--- a/Instructional_Response_to_SOL_Data_Reading.pptx
+++ b/Instructional_Response_to_SOL_Data_Reading.pptx
@@ -6368,7 +6368,7 @@
                       </a:pPr>
                       <a:r>
                         <a:rPr lang="en" sz="750" b="1"/>
-                        <a:t>Evaluate which details confirm or disprove an argument</a:t>
+                        <a:t>Evaluate details in a text, determining which could confirm or disprove an argument or position</a:t>
                       </a:r>
                       <a:r>
                         <a:rPr lang="en" sz="750"/>
@@ -6389,7 +6389,7 @@
                       </a:pPr>
                       <a:r>
                         <a:rPr lang="en" sz="750" b="1"/>
-                        <a:t>Analyze how dialogue and events reveal characters</a:t>
+                        <a:t>Analyze how characters are revealed through particular lines of dialogue or events</a:t>
                       </a:r>
                       <a:r>
                         <a:rPr lang="en" sz="750"/>
@@ -6410,7 +6410,7 @@
                       </a:pPr>
                       <a:r>
                         <a:rPr lang="en" sz="750" b="1"/>
-                        <a:t>Use context clues to clarify word meaning</a:t>
+                        <a:t>Use context and sentence structure clues to clarify the meaning of words</a:t>
                       </a:r>
                       <a:r>
                         <a:rPr lang="en" sz="750"/>
@@ -7303,7 +7303,7 @@
                       </a:pPr>
                       <a:r>
                         <a:rPr lang="en" sz="800" b="1"/>
-                        <a:t>Evaluate which details confirm or disprove an argument (10.RI.1.C)</a:t>
+                        <a:t>Evaluate details in a text, determining which could confirm or disprove an argument or position (10.RI.1.C)</a:t>
                       </a:r>
                       <a:endParaRPr sz="800"/>
                     </a:p>
@@ -7538,7 +7538,7 @@
                       </a:pPr>
                       <a:r>
                         <a:rPr lang="en" sz="800" b="1"/>
-                        <a:t>Analyze how dialogue and events reveal characters (11.RL.1.C)</a:t>
+                        <a:t>Analyze how characters are revealed through particular lines of dialogue or events (11.RL.1.C)</a:t>
                       </a:r>
                       <a:endParaRPr sz="800"/>
                     </a:p>
@@ -7773,7 +7773,7 @@
                       </a:pPr>
                       <a:r>
                         <a:rPr lang="en" sz="800" b="1"/>
-                        <a:t>Use context and sentence clues to clarify word meaning (11.RVN.1.B)</a:t>
+                        <a:t>Use context and sentence structure clues to clarify the meaning of words (11.RVN.1.B)</a:t>
                       </a:r>
                       <a:endParaRPr sz="800"/>
                     </a:p>
@@ -8609,7 +8609,7 @@
                   <a:srgbClr val="214F93"/>
                 </a:solidFill>
               </a:rPr>
-              <a:t>Evaluate which details confirm or disprove an argument</a:t>
+              <a:t>Evaluate details in a text, determining which could confirm or disprove an argument or position</a:t>
             </a:r>
           </a:p>
         </p:txBody>
@@ -9521,7 +9521,7 @@
                   <a:srgbClr val="214F93"/>
                 </a:solidFill>
               </a:rPr>
-              <a:t>Analyze how dialogue and events reveal characters</a:t>
+              <a:t>Analyze how characters are revealed through particular lines of dialogue or events</a:t>
             </a:r>
           </a:p>
         </p:txBody>
@@ -10433,7 +10433,7 @@
                   <a:srgbClr val="214F93"/>
                 </a:solidFill>
               </a:rPr>
-              <a:t>Use context clues to clarify word meaning</a:t>
+              <a:t>Use context and sentence structure clues to clarify the meaning of words</a:t>
             </a:r>
           </a:p>
         </p:txBody>

</xml_diff>

<commit_message>
Align Tier 1 changes on Reading slide with corrected priority gaps
Co-Authored-By: Claude Fable 5.1 <noreply@anthropic.com>
Claude-Session: https://claude.ai/code/session_01VxjrheVfSMgPoqBnV1z5LJ
</commit_message>
<xml_diff>
--- a/Instructional_Response_to_SOL_Data_Reading.pptx
+++ b/Instructional_Response_to_SOL_Data_Reading.pptx
@@ -6669,7 +6669,7 @@
                           <a:cs typeface="Arial"/>
                           <a:sym typeface="Arial"/>
                         </a:rPr>
-                        <a:t>Claim check:</a:t>
+                        <a:t>Claim check (10.RI.1.C):</a:t>
                       </a:r>
                       <a:r>
                         <a:rPr lang="en" sz="650">
@@ -6681,7 +6681,7 @@
                           <a:cs typeface="Arial"/>
                           <a:sym typeface="Arial"/>
                         </a:rPr>
-                        <a:t> bi-weekly paired-passage task analyzing details to confirm or disprove a claim; teacher think-aloud + PEE/CER.</a:t>
+                        <a:t> weekly paired-passage task sorting details that confirm vs. disprove a claim; teacher think-aloud + PEE/CER.</a:t>
                       </a:r>
                       <a:endParaRPr sz="650">
                         <a:solidFill>
@@ -6733,7 +6733,7 @@
                           <a:cs typeface="Arial"/>
                           <a:sym typeface="Arial"/>
                         </a:rPr>
-                        <a:t>Character annotation:</a:t>
+                        <a:t>Purpose &amp; technique analysis (11.RI.2.C):</a:t>
                       </a:r>
                       <a:r>
                         <a:rPr lang="en" sz="650">
@@ -6745,7 +6745,7 @@
                           <a:cs typeface="Arial"/>
                           <a:sym typeface="Arial"/>
                         </a:rPr>
-                        <a:t> written analytical paragraph of dialogue or an event explaining what  it reveals; organizer for SWD/ELL.</a:t>
+                        <a:t> students mark one literary technique and write: “The author uses [technique] to [effect]; this reveals [purpose].” Organizer + sentence starters for SWD/ELL.</a:t>
                       </a:r>
                       <a:endParaRPr sz="650">
                         <a:solidFill>
@@ -6797,7 +6797,7 @@
                           <a:cs typeface="Arial"/>
                           <a:sym typeface="Arial"/>
                         </a:rPr>
-                        <a:t>Context-clue routine:</a:t>
+                        <a:t>Word choice &amp; tone routine (11.RL.2.B):</a:t>
                       </a:r>
                       <a:r>
                         <a:rPr lang="en" sz="650">
@@ -6809,7 +6809,7 @@
                           <a:cs typeface="Arial"/>
                           <a:sym typeface="Arial"/>
                         </a:rPr>
-                        <a:t> weekly 5-10 minute word-meaning practice using context or word structure; pre-teach key words for ELL.</a:t>
+                        <a:t> daily 5-minute annotation of one word, syntax, or tone choice explaining how it conveys the author’s viewpoint; pre-teach key words for ELL.</a:t>
                       </a:r>
                       <a:endParaRPr sz="650">
                         <a:solidFill>

</xml_diff>

<commit_message>
Present MLL results as counts for the five-student SY2526 group
Only five MLL students appear in the SY2526 SDBQ (all on one test form), so MLL is shown as SY26 percent with correct/total and not trended against SY25's 49 students. Drops MLL-driven anomalies and the 11.RI.2.C "100%" as a finding.

Co-Authored-By: Claude Fable 5.1 <noreply@anthropic.com>
Claude-Session: https://claude.ai/code/session_01VxjrheVfSMgPoqBnV1z5LJ
</commit_message>
<xml_diff>
--- a/Instructional_Response_to_SOL_Data_Reading.pptx
+++ b/Instructional_Response_to_SOL_Data_Reading.pptx
@@ -6385,7 +6385,7 @@
                           <a:cs typeface="Arial"/>
                           <a:sym typeface="Arial"/>
                         </a:rPr>
-                        <a:t>% of items correct: all students 63%, SWD 49%, ELL 44%. Three skills to improve (all / SWD / ELL):</a:t>
+                        <a:t>% of items correct: all students 62%, SWD 49%, MLL 44%. Three priority skills (all / SWD / MLL; MLL reflects five students, shown with correct/total):</a:t>
                       </a:r>
                       <a:endParaRPr sz="650">
                         <a:solidFill>
@@ -6449,7 +6449,7 @@
                           <a:cs typeface="Arial"/>
                           <a:sym typeface="Arial"/>
                         </a:rPr>
-                        <a:t> (10.RI.1.C): 52% / 41% / 32%.</a:t>
+                        <a:t> (10.RI.1.C): 52% / 41% / 32% (8/25).</a:t>
                       </a:r>
                       <a:endParaRPr sz="650">
                         <a:solidFill>
@@ -6513,7 +6513,7 @@
                           <a:cs typeface="Arial"/>
                           <a:sym typeface="Arial"/>
                         </a:rPr>
-                        <a:t> (11.RI.2.C): 36% / 20% / 100%.</a:t>
+                        <a:t> (11.RI.2.C): 36% / 20% / 100% (5/5, one low-difficulty item).</a:t>
                       </a:r>
                       <a:endParaRPr sz="650">
                         <a:solidFill>
@@ -6577,7 +6577,7 @@
                           <a:cs typeface="Arial"/>
                           <a:sym typeface="Arial"/>
                         </a:rPr>
-                        <a:t> (11.RL.2.B): 58% / 41% / 20%.</a:t>
+                        <a:t> (11.RL.2.B): 58% / 41% / 20% (2/10).</a:t>
                       </a:r>
                       <a:endParaRPr sz="650">
                         <a:solidFill>
@@ -6745,7 +6745,7 @@
                           <a:cs typeface="Arial"/>
                           <a:sym typeface="Arial"/>
                         </a:rPr>
-                        <a:t> students mark one literary technique and write: “The author uses [technique] to [effect]; this reveals [purpose].” Organizer + sentence starters for SWD/ELL.</a:t>
+                        <a:t> students mark one literary technique and write: “The author uses [technique] to [effect]; this reveals [purpose].” Organizer + sentence starters for SWD/MLL.</a:t>
                       </a:r>
                       <a:endParaRPr sz="650">
                         <a:solidFill>
@@ -6809,7 +6809,7 @@
                           <a:cs typeface="Arial"/>
                           <a:sym typeface="Arial"/>
                         </a:rPr>
-                        <a:t> daily 5-minute annotation of one word, syntax, or tone choice explaining how it conveys the author’s viewpoint; pre-teach key words for ELL.</a:t>
+                        <a:t> daily 5-minute annotation of one word, syntax, or tone choice explaining how it conveys the author’s viewpoint; pre-teach key words for MLL.</a:t>
                       </a:r>
                       <a:endParaRPr sz="650">
                         <a:solidFill>
@@ -6889,7 +6889,7 @@
                           <a:cs typeface="Arial"/>
                           <a:sym typeface="Arial"/>
                         </a:rPr>
-                        <a:t>•One 5-item CFU per skill every 3 weeks; MP1 benchmark on these three SOLs for all/SWD/ELL.</a:t>
+                        <a:t>•One 5-item CFU per skill every 3 weeks; MP1 benchmark on these three SOLs for all/SWD/MLL.</a:t>
                       </a:r>
                       <a:endParaRPr sz="650">
                         <a:solidFill>

</xml_diff>

<commit_message>
Add Bloom's-level finding to Reading slide and Patterns slide
Evaluate items 64% -> 55%, analyze about steady at 62%, computed per item description. Tightens Reading column wording so Monitoring stays on the slide.

Co-Authored-By: Claude Opus 5.5 <noreply@anthropic.com>
Claude-Session: https://claude.ai/code/session_01VxjrheVfSMgPoqBnV1z5LJ
</commit_message>
<xml_diff>
--- a/Instructional_Response_to_SOL_Data_Reading.pptx
+++ b/Instructional_Response_to_SOL_Data_Reading.pptx
@@ -6385,7 +6385,7 @@
                           <a:cs typeface="Arial"/>
                           <a:sym typeface="Arial"/>
                         </a:rPr>
-                        <a:t>% of items correct: all students 62%, SWD 49%, MLL 44%. Three priority skills (all / SWD / MLL; MLL reflects five students, shown with correct/total):</a:t>
+                        <a:t>% correct: all 62%, SWD 49%, MLL 44% (five MLL students). Priority skills (all / SWD / MLL):</a:t>
                       </a:r>
                       <a:endParaRPr sz="650">
                         <a:solidFill>
@@ -6578,6 +6578,58 @@
                           <a:sym typeface="Arial"/>
                         </a:rPr>
                         <a:t> (11.RL.2.B): 58% / 41% / 20% (2/10).</a:t>
+                      </a:r>
+                      <a:endParaRPr sz="650">
+                        <a:solidFill>
+                          <a:schemeClr val="dk1"/>
+                        </a:solidFill>
+                        <a:latin typeface="Arial"/>
+                        <a:ea typeface="Arial"/>
+                        <a:cs typeface="Arial"/>
+                        <a:sym typeface="Arial"/>
+                      </a:endParaRPr>
+                    </a:p>
+                    <a:p>
+                      <a:pPr indent="0" lvl="0" marL="0" rtl="0" algn="l">
+                        <a:lnSpc>
+                          <a:spcPct val="115000"/>
+                        </a:lnSpc>
+                        <a:spcBef>
+                          <a:spcPts val="100"/>
+                        </a:spcBef>
+                        <a:spcAft>
+                          <a:spcPts val="0"/>
+                        </a:spcAft>
+                        <a:buClr>
+                          <a:schemeClr val="dk1"/>
+                        </a:buClr>
+                        <a:buSzPts val="1100"/>
+                        <a:buFont typeface="Arial"/>
+                        <a:buNone/>
+                      </a:pPr>
+                      <a:r>
+                        <a:rPr b="1" lang="en" sz="650">
+                          <a:solidFill>
+                            <a:schemeClr val="dk1"/>
+                          </a:solidFill>
+                          <a:latin typeface="Arial"/>
+                          <a:ea typeface="Arial"/>
+                          <a:cs typeface="Arial"/>
+                          <a:sym typeface="Arial"/>
+                        </a:rPr>
+                        <a:t>Bloom’s:</a:t>
+                      </a:r>
+                      <a:r>
+                        <a:rPr lang="en" sz="650">
+                          <a:solidFill>
+                            <a:schemeClr val="dk1"/>
+                          </a:solidFill>
+                          <a:latin typeface="Arial"/>
+                          <a:ea typeface="Arial"/>
+                          <a:cs typeface="Arial"/>
+                          <a:sym typeface="Arial"/>
+                        </a:rPr>
+                        <a:t xml:space="preserve"> all three are higher-order; evaluate items fell 64% to 55%, analyze held at 62%.</a:t>
                       </a:r>
                       <a:endParaRPr sz="650">
                         <a:solidFill>
@@ -6809,7 +6861,7 @@
                           <a:cs typeface="Arial"/>
                           <a:sym typeface="Arial"/>
                         </a:rPr>
-                        <a:t> daily 5-minute annotation of one word, syntax, or tone choice explaining how it conveys the author’s viewpoint; pre-teach key words for MLL.</a:t>
+                        <a:t> daily 5-minute annotation of one word or tone choice and the viewpoint it shows; pre-teach key words for MLL.</a:t>
                       </a:r>
                       <a:endParaRPr sz="650">
                         <a:solidFill>

</xml_diff>